<commit_message>
docs: Appended 89.1% ML Accuracy and Stage 2 Semantic upgrade specifications to Graduation Project Documents
</commit_message>
<xml_diff>
--- a/Bixah Ultimate Final Presentation.pptx
+++ b/Bixah Ultimate Final Presentation.pptx
@@ -28,6 +28,7 @@
     <p:sldId id="273" r:id="rId19"/>
     <p:sldId id="274" r:id="rId20"/>
     <p:sldId id="275" r:id="rId21"/>
+    <p:sldId id="276" r:id="rId27"/>
   </p:sldIdLst>
   <p:sldSz cx="9144000" cy="6858000" type="screen4x3"/>
   <p:notesSz cx="6858000" cy="9144000"/>
@@ -7850,6 +7851,85 @@
           </a:prstGeom>
         </p:spPr>
       </p:pic>
+    </p:spTree>
+  </p:cSld>
+  <p:clrMapOvr>
+    <a:masterClrMapping/>
+  </p:clrMapOvr>
+</p:sld>
+</file>
+
+<file path=ppt/slides/slide21.xml><?xml version="1.0" encoding="utf-8"?>
+<p:sld xmlns:a="http://schemas.openxmlformats.org/drawingml/2006/main" xmlns:p="http://schemas.openxmlformats.org/presentationml/2006/main" xmlns:r="http://schemas.openxmlformats.org/officeDocument/2006/relationships">
+  <p:cSld>
+    <p:spTree>
+      <p:nvGrpSpPr>
+        <p:cNvPr id="1" name=""/>
+        <p:cNvGrpSpPr/>
+        <p:nvPr/>
+      </p:nvGrpSpPr>
+      <p:grpSpPr/>
+      <p:sp>
+        <p:nvSpPr>
+          <p:cNvPr id="2" name="Title 1"/>
+          <p:cNvSpPr>
+            <a:spLocks noGrp="1"/>
+          </p:cNvSpPr>
+          <p:nvPr>
+            <p:ph type="title"/>
+          </p:nvPr>
+        </p:nvSpPr>
+        <p:spPr/>
+        <p:txBody>
+          <a:bodyPr/>
+          <a:lstStyle/>
+          <a:p>
+            <a:r>
+              <a:t>March 2026 Semantic Model Refit</a:t>
+            </a:r>
+          </a:p>
+        </p:txBody>
+      </p:sp>
+      <p:sp>
+        <p:nvSpPr>
+          <p:cNvPr id="3" name="Content Placeholder 2"/>
+          <p:cNvSpPr>
+            <a:spLocks noGrp="1"/>
+          </p:cNvSpPr>
+          <p:nvPr>
+            <p:ph idx="1"/>
+          </p:nvPr>
+        </p:nvSpPr>
+        <p:spPr/>
+        <p:txBody>
+          <a:bodyPr/>
+          <a:lstStyle/>
+          <a:p>
+            <a:r>
+              <a:t>Bixah Ultimate's offline ML accuracy was boosted to 89.1% by retraining the AI on 1 Million links using new deep semantic features:</a:t>
+            </a:r>
+          </a:p>
+          <a:p/>
+          <a:p>
+            <a:pPr lvl="1"/>
+            <a:r>
+              <a:t>Vowel-to-Consonant tracking for Gibson-like gibberish domain detection.</a:t>
+            </a:r>
+          </a:p>
+          <a:p>
+            <a:pPr lvl="1"/>
+            <a:r>
+              <a:t>Independently tracked threat vectors ('scam', 'finance', 'login').</a:t>
+            </a:r>
+          </a:p>
+          <a:p>
+            <a:pPr lvl="1"/>
+            <a:r>
+              <a:t>Stage 1 structural vocabulary expanded to 150,000 text limits.</a:t>
+            </a:r>
+          </a:p>
+        </p:txBody>
+      </p:sp>
     </p:spTree>
   </p:cSld>
   <p:clrMapOvr>

</xml_diff>